<commit_message>
Fix catalog numeric semantics, evidence checks and portable CLI
</commit_message>
<xml_diff>
--- a/catalog/samples/scenario_lines_cagr.pptx
+++ b/catalog/samples/scenario_lines_cagr.pptx
@@ -205,19 +205,19 @@
                   <c:v>2026</c:v>
                 </c:pt>
                 <c:pt idx="1">
-                  <c:v>2026</c:v>
+                  <c:v>2027</c:v>
                 </c:pt>
                 <c:pt idx="2">
-                  <c:v>2026</c:v>
+                  <c:v>2028</c:v>
                 </c:pt>
                 <c:pt idx="3">
-                  <c:v>2026</c:v>
+                  <c:v>2029</c:v>
                 </c:pt>
                 <c:pt idx="4">
-                  <c:v>2026</c:v>
+                  <c:v>2030</c:v>
                 </c:pt>
                 <c:pt idx="5">
-                  <c:v>2026</c:v>
+                  <c:v>2031</c:v>
                 </c:pt>
               </c:strCache>
             </c:strRef>
@@ -329,19 +329,19 @@
                   <c:v>2026</c:v>
                 </c:pt>
                 <c:pt idx="1">
-                  <c:v>2026</c:v>
+                  <c:v>2027</c:v>
                 </c:pt>
                 <c:pt idx="2">
-                  <c:v>2026</c:v>
+                  <c:v>2028</c:v>
                 </c:pt>
                 <c:pt idx="3">
-                  <c:v>2026</c:v>
+                  <c:v>2029</c:v>
                 </c:pt>
                 <c:pt idx="4">
-                  <c:v>2026</c:v>
+                  <c:v>2030</c:v>
                 </c:pt>
                 <c:pt idx="5">
-                  <c:v>2026</c:v>
+                  <c:v>2031</c:v>
                 </c:pt>
               </c:strCache>
             </c:strRef>
@@ -453,19 +453,19 @@
                   <c:v>2026</c:v>
                 </c:pt>
                 <c:pt idx="1">
-                  <c:v>2026</c:v>
+                  <c:v>2027</c:v>
                 </c:pt>
                 <c:pt idx="2">
-                  <c:v>2026</c:v>
+                  <c:v>2028</c:v>
                 </c:pt>
                 <c:pt idx="3">
-                  <c:v>2026</c:v>
+                  <c:v>2029</c:v>
                 </c:pt>
                 <c:pt idx="4">
-                  <c:v>2026</c:v>
+                  <c:v>2030</c:v>
                 </c:pt>
                 <c:pt idx="5">
-                  <c:v>2026</c:v>
+                  <c:v>2031</c:v>
                 </c:pt>
               </c:strCache>
             </c:strRef>
@@ -1059,7 +1059,7 @@
           </a:p>
           <a:p>
             <a:r>
-              <a:t>  "source_sha256": "fd6956ff980f173772bee20ad903ac844b11b31f8baf2d6a4bc82c07ba93601a",</a:t>
+              <a:t>  "source_sha256": "d9e6314d0655f2b87a386536b251b5fbde35ed2fbdf39d8be04e2e06ef8f4c58",</a:t>
             </a:r>
           </a:p>
           <a:p>
@@ -1224,7 +1224,7 @@
           </a:p>
           <a:p>
             <a:r>
-              <a:t>      "text": "単位、2026〜2026年",</a:t>
+              <a:t>      "text": "単位、2026〜2031年",</a:t>
             </a:r>
           </a:p>
           <a:p>
@@ -1244,7 +1244,7 @@
           </a:p>
           <a:p>
             <a:r>
-              <a:t>          "quote": "単位、2026〜2026年"</a:t>
+              <a:t>          "quote": "単位、2026〜2031年"</a:t>
             </a:r>
           </a:p>
           <a:p>
@@ -1274,7 +1274,7 @@
           </a:p>
           <a:p>
             <a:r>
-              <a:t>      "text": "年平均成長率",</a:t>
+              <a:t>      "text": "2026",</a:t>
             </a:r>
           </a:p>
           <a:p>
@@ -1294,7 +1294,7 @@
           </a:p>
           <a:p>
             <a:r>
-              <a:t>          "quote": "年平均成長率"</a:t>
+              <a:t>          "quote": "2026"</a:t>
             </a:r>
           </a:p>
           <a:p>
@@ -1324,7 +1324,7 @@
           </a:p>
           <a:p>
             <a:r>
-              <a:t>      "text": "2026",</a:t>
+              <a:t>      "text": "2027",</a:t>
             </a:r>
           </a:p>
           <a:p>
@@ -1344,7 +1344,7 @@
           </a:p>
           <a:p>
             <a:r>
-              <a:t>          "quote": "2026"</a:t>
+              <a:t>          "quote": "2027"</a:t>
             </a:r>
           </a:p>
           <a:p>
@@ -1374,7 +1374,7 @@
           </a:p>
           <a:p>
             <a:r>
-              <a:t>      "text": "2026",</a:t>
+              <a:t>      "text": "2028",</a:t>
             </a:r>
           </a:p>
           <a:p>
@@ -1394,7 +1394,7 @@
           </a:p>
           <a:p>
             <a:r>
-              <a:t>          "quote": "2026"</a:t>
+              <a:t>          "quote": "2028"</a:t>
             </a:r>
           </a:p>
           <a:p>
@@ -1424,7 +1424,7 @@
           </a:p>
           <a:p>
             <a:r>
-              <a:t>      "text": "2026",</a:t>
+              <a:t>      "text": "2029",</a:t>
             </a:r>
           </a:p>
           <a:p>
@@ -1444,7 +1444,7 @@
           </a:p>
           <a:p>
             <a:r>
-              <a:t>          "quote": "2026"</a:t>
+              <a:t>          "quote": "2029"</a:t>
             </a:r>
           </a:p>
           <a:p>
@@ -1474,7 +1474,7 @@
           </a:p>
           <a:p>
             <a:r>
-              <a:t>      "text": "2026",</a:t>
+              <a:t>      "text": "2030",</a:t>
             </a:r>
           </a:p>
           <a:p>
@@ -1494,7 +1494,7 @@
           </a:p>
           <a:p>
             <a:r>
-              <a:t>          "quote": "2026"</a:t>
+              <a:t>          "quote": "2030"</a:t>
             </a:r>
           </a:p>
           <a:p>
@@ -1524,7 +1524,7 @@
           </a:p>
           <a:p>
             <a:r>
-              <a:t>      "text": "2026",</a:t>
+              <a:t>      "text": "2031",</a:t>
             </a:r>
           </a:p>
           <a:p>
@@ -1544,7 +1544,7 @@
           </a:p>
           <a:p>
             <a:r>
-              <a:t>          "quote": "2026"</a:t>
+              <a:t>          "quote": "2031"</a:t>
             </a:r>
           </a:p>
           <a:p>
@@ -1574,7 +1574,7 @@
           </a:p>
           <a:p>
             <a:r>
-              <a:t>      "text": "2026",</a:t>
+              <a:t>      "text": "上振れ",</a:t>
             </a:r>
           </a:p>
           <a:p>
@@ -1594,7 +1594,7 @@
           </a:p>
           <a:p>
             <a:r>
-              <a:t>          "quote": "2026"</a:t>
+              <a:t>          "quote": "上振れ"</a:t>
             </a:r>
           </a:p>
           <a:p>
@@ -1624,7 +1624,7 @@
           </a:p>
           <a:p>
             <a:r>
-              <a:t>      "text": "上振れ",</a:t>
+              <a:t>      "value": 35.0,</a:t>
             </a:r>
           </a:p>
           <a:p>
@@ -1644,7 +1644,7 @@
           </a:p>
           <a:p>
             <a:r>
-              <a:t>          "quote": "上振れ"</a:t>
+              <a:t>          "quote": "35"</a:t>
             </a:r>
           </a:p>
           <a:p>
@@ -1654,6 +1654,276 @@
           </a:p>
           <a:p>
             <a:r>
+              <a:t>      ]</a:t>
+            </a:r>
+          </a:p>
+          <a:p>
+            <a:r>
+              <a:t>    },</a:t>
+            </a:r>
+          </a:p>
+          <a:p>
+            <a:r>
+              <a:t>    {</a:t>
+            </a:r>
+          </a:p>
+          <a:p>
+            <a:r>
+              <a:t>      "value": 44.0,</a:t>
+            </a:r>
+          </a:p>
+          <a:p>
+            <a:r>
+              <a:t>      "refs": [</a:t>
+            </a:r>
+          </a:p>
+          <a:p>
+            <a:r>
+              <a:t>        {</a:t>
+            </a:r>
+          </a:p>
+          <a:p>
+            <a:r>
+              <a:t>          "source_id": "s001",</a:t>
+            </a:r>
+          </a:p>
+          <a:p>
+            <a:r>
+              <a:t>          "quote": "44"</a:t>
+            </a:r>
+          </a:p>
+          <a:p>
+            <a:r>
+              <a:t>        }</a:t>
+            </a:r>
+          </a:p>
+          <a:p>
+            <a:r>
+              <a:t>      ]</a:t>
+            </a:r>
+          </a:p>
+          <a:p>
+            <a:r>
+              <a:t>    },</a:t>
+            </a:r>
+          </a:p>
+          <a:p>
+            <a:r>
+              <a:t>    {</a:t>
+            </a:r>
+          </a:p>
+          <a:p>
+            <a:r>
+              <a:t>      "value": 56.0,</a:t>
+            </a:r>
+          </a:p>
+          <a:p>
+            <a:r>
+              <a:t>      "refs": [</a:t>
+            </a:r>
+          </a:p>
+          <a:p>
+            <a:r>
+              <a:t>        {</a:t>
+            </a:r>
+          </a:p>
+          <a:p>
+            <a:r>
+              <a:t>          "source_id": "s001",</a:t>
+            </a:r>
+          </a:p>
+          <a:p>
+            <a:r>
+              <a:t>          "quote": "56"</a:t>
+            </a:r>
+          </a:p>
+          <a:p>
+            <a:r>
+              <a:t>        }</a:t>
+            </a:r>
+          </a:p>
+          <a:p>
+            <a:r>
+              <a:t>      ]</a:t>
+            </a:r>
+          </a:p>
+          <a:p>
+            <a:r>
+              <a:t>    },</a:t>
+            </a:r>
+          </a:p>
+          <a:p>
+            <a:r>
+              <a:t>    {</a:t>
+            </a:r>
+          </a:p>
+          <a:p>
+            <a:r>
+              <a:t>      "value": 72.0,</a:t>
+            </a:r>
+          </a:p>
+          <a:p>
+            <a:r>
+              <a:t>      "refs": [</a:t>
+            </a:r>
+          </a:p>
+          <a:p>
+            <a:r>
+              <a:t>        {</a:t>
+            </a:r>
+          </a:p>
+          <a:p>
+            <a:r>
+              <a:t>          "source_id": "s001",</a:t>
+            </a:r>
+          </a:p>
+          <a:p>
+            <a:r>
+              <a:t>          "quote": "72"</a:t>
+            </a:r>
+          </a:p>
+          <a:p>
+            <a:r>
+              <a:t>        }</a:t>
+            </a:r>
+          </a:p>
+          <a:p>
+            <a:r>
+              <a:t>      ]</a:t>
+            </a:r>
+          </a:p>
+          <a:p>
+            <a:r>
+              <a:t>    },</a:t>
+            </a:r>
+          </a:p>
+          <a:p>
+            <a:r>
+              <a:t>    {</a:t>
+            </a:r>
+          </a:p>
+          <a:p>
+            <a:r>
+              <a:t>      "value": 91.0,</a:t>
+            </a:r>
+          </a:p>
+          <a:p>
+            <a:r>
+              <a:t>      "refs": [</a:t>
+            </a:r>
+          </a:p>
+          <a:p>
+            <a:r>
+              <a:t>        {</a:t>
+            </a:r>
+          </a:p>
+          <a:p>
+            <a:r>
+              <a:t>          "source_id": "s001",</a:t>
+            </a:r>
+          </a:p>
+          <a:p>
+            <a:r>
+              <a:t>          "quote": "91"</a:t>
+            </a:r>
+          </a:p>
+          <a:p>
+            <a:r>
+              <a:t>        }</a:t>
+            </a:r>
+          </a:p>
+          <a:p>
+            <a:r>
+              <a:t>      ]</a:t>
+            </a:r>
+          </a:p>
+          <a:p>
+            <a:r>
+              <a:t>    },</a:t>
+            </a:r>
+          </a:p>
+          <a:p>
+            <a:r>
+              <a:t>    {</a:t>
+            </a:r>
+          </a:p>
+          <a:p>
+            <a:r>
+              <a:t>      "value": 114.0,</a:t>
+            </a:r>
+          </a:p>
+          <a:p>
+            <a:r>
+              <a:t>      "refs": [</a:t>
+            </a:r>
+          </a:p>
+          <a:p>
+            <a:r>
+              <a:t>        {</a:t>
+            </a:r>
+          </a:p>
+          <a:p>
+            <a:r>
+              <a:t>          "source_id": "s001",</a:t>
+            </a:r>
+          </a:p>
+          <a:p>
+            <a:r>
+              <a:t>          "quote": "114"</a:t>
+            </a:r>
+          </a:p>
+          <a:p>
+            <a:r>
+              <a:t>        }</a:t>
+            </a:r>
+          </a:p>
+          <a:p>
+            <a:r>
+              <a:t>      ]</a:t>
+            </a:r>
+          </a:p>
+          <a:p>
+            <a:r>
+              <a:t>    },</a:t>
+            </a:r>
+          </a:p>
+          <a:p>
+            <a:r>
+              <a:t>    {</a:t>
+            </a:r>
+          </a:p>
+          <a:p>
+            <a:r>
+              <a:t>      "text": "基準",</a:t>
+            </a:r>
+          </a:p>
+          <a:p>
+            <a:r>
+              <a:t>      "refs": [</a:t>
+            </a:r>
+          </a:p>
+          <a:p>
+            <a:r>
+              <a:t>        {</a:t>
+            </a:r>
+          </a:p>
+          <a:p>
+            <a:r>
+              <a:t>          "source_id": "s001",</a:t>
+            </a:r>
+          </a:p>
+          <a:p>
+            <a:r>
+              <a:t>          "quote": "基準"</a:t>
+            </a:r>
+          </a:p>
+          <a:p>
+            <a:r>
+              <a:t>        }</a:t>
+            </a:r>
+          </a:p>
+          <a:p>
+            <a:r>
               <a:t>      ],</a:t>
             </a:r>
           </a:p>
@@ -1719,7 +1989,7 @@
           </a:p>
           <a:p>
             <a:r>
-              <a:t>      "value": 44.0,</a:t>
+              <a:t>      "value": 43.0,</a:t>
             </a:r>
           </a:p>
           <a:p>
@@ -1739,7 +2009,7 @@
           </a:p>
           <a:p>
             <a:r>
-              <a:t>          "quote": "44"</a:t>
+              <a:t>          "quote": "43"</a:t>
             </a:r>
           </a:p>
           <a:p>
@@ -1764,7 +2034,7 @@
           </a:p>
           <a:p>
             <a:r>
-              <a:t>      "value": 56.0,</a:t>
+              <a:t>      "value": 53.0,</a:t>
             </a:r>
           </a:p>
           <a:p>
@@ -1784,7 +2054,7 @@
           </a:p>
           <a:p>
             <a:r>
-              <a:t>          "quote": "56"</a:t>
+              <a:t>          "quote": "53"</a:t>
             </a:r>
           </a:p>
           <a:p>
@@ -1809,7 +2079,7 @@
           </a:p>
           <a:p>
             <a:r>
-              <a:t>      "value": 72.0,</a:t>
+              <a:t>      "value": 65.0,</a:t>
             </a:r>
           </a:p>
           <a:p>
@@ -1829,7 +2099,7 @@
           </a:p>
           <a:p>
             <a:r>
-              <a:t>          "quote": "72"</a:t>
+              <a:t>          "quote": "65"</a:t>
             </a:r>
           </a:p>
           <a:p>
@@ -1854,7 +2124,7 @@
           </a:p>
           <a:p>
             <a:r>
-              <a:t>      "value": 91.0,</a:t>
+              <a:t>      "value": 80.0,</a:t>
             </a:r>
           </a:p>
           <a:p>
@@ -1874,7 +2144,7 @@
           </a:p>
           <a:p>
             <a:r>
-              <a:t>          "quote": "91"</a:t>
+              <a:t>          "quote": "80"</a:t>
             </a:r>
           </a:p>
           <a:p>
@@ -1899,7 +2169,7 @@
           </a:p>
           <a:p>
             <a:r>
-              <a:t>      "value": 114.0,</a:t>
+              <a:t>      "value": 96.0,</a:t>
             </a:r>
           </a:p>
           <a:p>
@@ -1919,7 +2189,7 @@
           </a:p>
           <a:p>
             <a:r>
-              <a:t>          "quote": "114"</a:t>
+              <a:t>          "quote": "96"</a:t>
             </a:r>
           </a:p>
           <a:p>
@@ -1944,7 +2214,7 @@
           </a:p>
           <a:p>
             <a:r>
-              <a:t>      "text": "基準",</a:t>
+              <a:t>      "text": "下振れ",</a:t>
             </a:r>
           </a:p>
           <a:p>
@@ -1964,7 +2234,7 @@
           </a:p>
           <a:p>
             <a:r>
-              <a:t>          "quote": "基準"</a:t>
+              <a:t>          "quote": "下振れ"</a:t>
             </a:r>
           </a:p>
           <a:p>
@@ -2039,7 +2309,7 @@
           </a:p>
           <a:p>
             <a:r>
-              <a:t>      "value": 43.0,</a:t>
+              <a:t>      "value": 42.0,</a:t>
             </a:r>
           </a:p>
           <a:p>
@@ -2059,7 +2329,7 @@
           </a:p>
           <a:p>
             <a:r>
-              <a:t>          "quote": "43"</a:t>
+              <a:t>          "quote": "42"</a:t>
             </a:r>
           </a:p>
           <a:p>
@@ -2084,7 +2354,7 @@
           </a:p>
           <a:p>
             <a:r>
-              <a:t>      "value": 53.0,</a:t>
+              <a:t>      "value": 50.0,</a:t>
             </a:r>
           </a:p>
           <a:p>
@@ -2104,7 +2374,7 @@
           </a:p>
           <a:p>
             <a:r>
-              <a:t>          "quote": "53"</a:t>
+              <a:t>          "quote": "50"</a:t>
             </a:r>
           </a:p>
           <a:p>
@@ -2129,7 +2399,7 @@
           </a:p>
           <a:p>
             <a:r>
-              <a:t>      "value": 65.0,</a:t>
+              <a:t>      "value": 59.0,</a:t>
             </a:r>
           </a:p>
           <a:p>
@@ -2149,7 +2419,7 @@
           </a:p>
           <a:p>
             <a:r>
-              <a:t>          "quote": "65"</a:t>
+              <a:t>          "quote": "59"</a:t>
             </a:r>
           </a:p>
           <a:p>
@@ -2174,7 +2444,7 @@
           </a:p>
           <a:p>
             <a:r>
-              <a:t>      "value": 80.0,</a:t>
+              <a:t>      "value": 70.0,</a:t>
             </a:r>
           </a:p>
           <a:p>
@@ -2194,7 +2464,7 @@
           </a:p>
           <a:p>
             <a:r>
-              <a:t>          "quote": "80"</a:t>
+              <a:t>          "quote": "70"</a:t>
             </a:r>
           </a:p>
           <a:p>
@@ -2219,7 +2489,7 @@
           </a:p>
           <a:p>
             <a:r>
-              <a:t>      "value": 96.0,</a:t>
+              <a:t>      "value": 81.0,</a:t>
             </a:r>
           </a:p>
           <a:p>
@@ -2239,7 +2509,7 @@
           </a:p>
           <a:p>
             <a:r>
-              <a:t>          "quote": "96"</a:t>
+              <a:t>          "quote": "81"</a:t>
             </a:r>
           </a:p>
           <a:p>
@@ -2264,7 +2534,7 @@
           </a:p>
           <a:p>
             <a:r>
-              <a:t>      "text": "下振れ",</a:t>
+              <a:t>      "value": 5.0,</a:t>
             </a:r>
           </a:p>
           <a:p>
@@ -2284,7 +2554,7 @@
           </a:p>
           <a:p>
             <a:r>
-              <a:t>          "quote": "下振れ"</a:t>
+              <a:t>          "quote": "5"</a:t>
             </a:r>
           </a:p>
           <a:p>
@@ -2294,286 +2564,11 @@
           </a:p>
           <a:p>
             <a:r>
-              <a:t>      ],</a:t>
-            </a:r>
-          </a:p>
-          <a:p>
-            <a:r>
-              <a:t>      "mode": "verbatim"</a:t>
-            </a:r>
-          </a:p>
-          <a:p>
-            <a:r>
-              <a:t>    },</a:t>
-            </a:r>
-          </a:p>
-          <a:p>
-            <a:r>
-              <a:t>    {</a:t>
-            </a:r>
-          </a:p>
-          <a:p>
-            <a:r>
-              <a:t>      "value": 35.0,</a:t>
-            </a:r>
-          </a:p>
-          <a:p>
-            <a:r>
-              <a:t>      "refs": [</a:t>
-            </a:r>
-          </a:p>
-          <a:p>
-            <a:r>
-              <a:t>        {</a:t>
-            </a:r>
-          </a:p>
-          <a:p>
-            <a:r>
-              <a:t>          "source_id": "s001",</a:t>
-            </a:r>
-          </a:p>
-          <a:p>
-            <a:r>
-              <a:t>          "quote": "35"</a:t>
-            </a:r>
-          </a:p>
-          <a:p>
-            <a:r>
-              <a:t>        }</a:t>
-            </a:r>
-          </a:p>
-          <a:p>
-            <a:r>
               <a:t>      ]</a:t>
             </a:r>
           </a:p>
           <a:p>
             <a:r>
-              <a:t>    },</a:t>
-            </a:r>
-          </a:p>
-          <a:p>
-            <a:r>
-              <a:t>    {</a:t>
-            </a:r>
-          </a:p>
-          <a:p>
-            <a:r>
-              <a:t>      "value": 42.0,</a:t>
-            </a:r>
-          </a:p>
-          <a:p>
-            <a:r>
-              <a:t>      "refs": [</a:t>
-            </a:r>
-          </a:p>
-          <a:p>
-            <a:r>
-              <a:t>        {</a:t>
-            </a:r>
-          </a:p>
-          <a:p>
-            <a:r>
-              <a:t>          "source_id": "s001",</a:t>
-            </a:r>
-          </a:p>
-          <a:p>
-            <a:r>
-              <a:t>          "quote": "42"</a:t>
-            </a:r>
-          </a:p>
-          <a:p>
-            <a:r>
-              <a:t>        }</a:t>
-            </a:r>
-          </a:p>
-          <a:p>
-            <a:r>
-              <a:t>      ]</a:t>
-            </a:r>
-          </a:p>
-          <a:p>
-            <a:r>
-              <a:t>    },</a:t>
-            </a:r>
-          </a:p>
-          <a:p>
-            <a:r>
-              <a:t>    {</a:t>
-            </a:r>
-          </a:p>
-          <a:p>
-            <a:r>
-              <a:t>      "value": 50.0,</a:t>
-            </a:r>
-          </a:p>
-          <a:p>
-            <a:r>
-              <a:t>      "refs": [</a:t>
-            </a:r>
-          </a:p>
-          <a:p>
-            <a:r>
-              <a:t>        {</a:t>
-            </a:r>
-          </a:p>
-          <a:p>
-            <a:r>
-              <a:t>          "source_id": "s001",</a:t>
-            </a:r>
-          </a:p>
-          <a:p>
-            <a:r>
-              <a:t>          "quote": "50"</a:t>
-            </a:r>
-          </a:p>
-          <a:p>
-            <a:r>
-              <a:t>        }</a:t>
-            </a:r>
-          </a:p>
-          <a:p>
-            <a:r>
-              <a:t>      ]</a:t>
-            </a:r>
-          </a:p>
-          <a:p>
-            <a:r>
-              <a:t>    },</a:t>
-            </a:r>
-          </a:p>
-          <a:p>
-            <a:r>
-              <a:t>    {</a:t>
-            </a:r>
-          </a:p>
-          <a:p>
-            <a:r>
-              <a:t>      "value": 59.0,</a:t>
-            </a:r>
-          </a:p>
-          <a:p>
-            <a:r>
-              <a:t>      "refs": [</a:t>
-            </a:r>
-          </a:p>
-          <a:p>
-            <a:r>
-              <a:t>        {</a:t>
-            </a:r>
-          </a:p>
-          <a:p>
-            <a:r>
-              <a:t>          "source_id": "s001",</a:t>
-            </a:r>
-          </a:p>
-          <a:p>
-            <a:r>
-              <a:t>          "quote": "59"</a:t>
-            </a:r>
-          </a:p>
-          <a:p>
-            <a:r>
-              <a:t>        }</a:t>
-            </a:r>
-          </a:p>
-          <a:p>
-            <a:r>
-              <a:t>      ]</a:t>
-            </a:r>
-          </a:p>
-          <a:p>
-            <a:r>
-              <a:t>    },</a:t>
-            </a:r>
-          </a:p>
-          <a:p>
-            <a:r>
-              <a:t>    {</a:t>
-            </a:r>
-          </a:p>
-          <a:p>
-            <a:r>
-              <a:t>      "value": 70.0,</a:t>
-            </a:r>
-          </a:p>
-          <a:p>
-            <a:r>
-              <a:t>      "refs": [</a:t>
-            </a:r>
-          </a:p>
-          <a:p>
-            <a:r>
-              <a:t>        {</a:t>
-            </a:r>
-          </a:p>
-          <a:p>
-            <a:r>
-              <a:t>          "source_id": "s001",</a:t>
-            </a:r>
-          </a:p>
-          <a:p>
-            <a:r>
-              <a:t>          "quote": "70"</a:t>
-            </a:r>
-          </a:p>
-          <a:p>
-            <a:r>
-              <a:t>        }</a:t>
-            </a:r>
-          </a:p>
-          <a:p>
-            <a:r>
-              <a:t>      ]</a:t>
-            </a:r>
-          </a:p>
-          <a:p>
-            <a:r>
-              <a:t>    },</a:t>
-            </a:r>
-          </a:p>
-          <a:p>
-            <a:r>
-              <a:t>    {</a:t>
-            </a:r>
-          </a:p>
-          <a:p>
-            <a:r>
-              <a:t>      "value": 81.0,</a:t>
-            </a:r>
-          </a:p>
-          <a:p>
-            <a:r>
-              <a:t>      "refs": [</a:t>
-            </a:r>
-          </a:p>
-          <a:p>
-            <a:r>
-              <a:t>        {</a:t>
-            </a:r>
-          </a:p>
-          <a:p>
-            <a:r>
-              <a:t>          "source_id": "s001",</a:t>
-            </a:r>
-          </a:p>
-          <a:p>
-            <a:r>
-              <a:t>          "quote": "81"</a:t>
-            </a:r>
-          </a:p>
-          <a:p>
-            <a:r>
-              <a:t>        }</a:t>
-            </a:r>
-          </a:p>
-          <a:p>
-            <a:r>
-              <a:t>      ]</a:t>
-            </a:r>
-          </a:p>
-          <a:p>
-            <a:r>
               <a:t>    }</a:t>
             </a:r>
           </a:p>
@@ -2609,7 +2604,7 @@
           </a:p>
           <a:p>
             <a:r>
-              <a:t>  "template_sha256": "27305ae8945ae4eab4b9cd98b237a7e286b28d4cb36cc51ab21d39d8846e680c"</a:t>
+              <a:t>  "template_sha256": "4a181913166f5122988f15391fe6324503cc0f2143d77cf77d18805dd9bb71fd"</a:t>
             </a:r>
           </a:p>
           <a:p>
@@ -6036,7 +6031,7 @@
                 <a:ea typeface="Yu Gothic" pitchFamily="34" charset="-122"/>
                 <a:cs typeface="Yu Gothic" pitchFamily="34" charset="-120"/>
               </a:rPr>
-              <a:t>単位、2026〜2026年</a:t>
+              <a:t>単位、2026〜2031年</a:t>
             </a:r>
             <a:endParaRPr lang="en-US" sz="850" dirty="0"/>
           </a:p>
@@ -6216,7 +6211,7 @@
                 <a:ea typeface="Yu Gothic" pitchFamily="34" charset="-122"/>
                 <a:cs typeface="Yu Gothic" pitchFamily="34" charset="-120"/>
               </a:rPr>
-              <a:t>年平均成長率</a:t>
+              <a:t>年平均成長率（5年）</a:t>
             </a:r>
             <a:endParaRPr lang="en-US" sz="1000" dirty="0"/>
           </a:p>

</xml_diff>